<commit_message>
Add presentation slides generator with initial setup
- Created package.json for project metadata and dependencies.
- Added package-lock.json for dependency management.
- Included initial PPTX file for the graduation project presentation.
</commit_message>
<xml_diff>
--- a/06-final-report/figures/fig-4-module-structure.pptx
+++ b/06-final-report/figures/fig-4-module-structure.pptx
@@ -1965,7 +1965,7 @@
                 <a:ea typeface="맑은 고딕" pitchFamily="34" charset="-122"/>
                 <a:cs typeface="맑은 고딕" pitchFamily="34" charset="-120"/>
               </a:rPr>
-              <a:t>rate-limiter/</a:t>
+              <a:t>utils/</a:t>
             </a:r>
             <a:endParaRPr lang="en-US" sz="900" dirty="0"/>
           </a:p>
@@ -1982,7 +1982,7 @@
                 <a:ea typeface="맑은 고딕" pitchFamily="34" charset="-122"/>
                 <a:cs typeface="맑은 고딕" pitchFamily="34" charset="-120"/>
               </a:rPr>
-              <a:t>(요청 제한)</a:t>
+              <a:t>rateLimiter.js (요청 제한)</a:t>
             </a:r>
             <a:endParaRPr lang="en-US" sz="900" dirty="0"/>
           </a:p>

</xml_diff>